<commit_message>
docs: lay the agenda out in two columns
A single column used less than half a 16:9 canvas, leaving the right-hand 54%
empty and the slide reading half-finished. Split 4 + 3 across two columns, with
the row pitch opened up so the taller column reaches about the same depth as the
content on the other slides, and a hairline between the columns so the split
reads as deliberate structure rather than a wrap.

Item 6's sub-line had to be shortened -- at the narrower column width it wrapped
and orphaned "numbers" on its own line.

Verified on the render: all seven numbered chips present, seven entries, nothing
wrapping, both columns clear of the divider and the slide edges.

Co-Authored-By: Claude Opus 4.8 <noreply@anthropic.com>
</commit_message>
<xml_diff>
--- a/docs/BenchmarkingService.pptx
+++ b/docs/BenchmarkingService.pptx
@@ -4391,8 +4391,8 @@
         </p:nvSpPr>
         <p:spPr>
           <a:xfrm>
-            <a:off x="685800" y="1298448"/>
-            <a:ext cx="384048" cy="384048"/>
+            <a:off x="685800" y="1472184"/>
+            <a:ext cx="420624" cy="420624"/>
           </a:xfrm>
           <a:prstGeom prst="ellipse">
             <a:avLst/>
@@ -4427,7 +4427,7 @@
           <a:p>
             <a:pPr algn="ctr"/>
             <a:r>
-              <a:rPr sz="1300" b="1" i="0">
+              <a:rPr sz="1400" b="1" i="0">
                 <a:solidFill>
                   <a:srgbClr val="FFFFFF"/>
                 </a:solidFill>
@@ -4446,8 +4446,8 @@
         </p:nvSpPr>
         <p:spPr>
           <a:xfrm>
-            <a:off x="1280160" y="1234440"/>
-            <a:ext cx="10332720" cy="274320"/>
+            <a:off x="1280160" y="1417320"/>
+            <a:ext cx="4526280" cy="292608"/>
           </a:xfrm>
           <a:prstGeom prst="rect">
             <a:avLst/>
@@ -4466,7 +4466,7 @@
               </a:spcAft>
             </a:pPr>
             <a:r>
-              <a:rPr sz="1600" b="1" i="0">
+              <a:rPr sz="1700" b="1" i="0">
                 <a:solidFill>
                   <a:srgbClr val="1B3A5C"/>
                 </a:solidFill>
@@ -4485,8 +4485,8 @@
         </p:nvSpPr>
         <p:spPr>
           <a:xfrm>
-            <a:off x="1280160" y="1508760"/>
-            <a:ext cx="10332720" cy="256032"/>
+            <a:off x="1280160" y="1719072"/>
+            <a:ext cx="4526280" cy="457200"/>
           </a:xfrm>
           <a:prstGeom prst="rect">
             <a:avLst/>
@@ -4505,7 +4505,7 @@
               </a:spcAft>
             </a:pPr>
             <a:r>
-              <a:rPr sz="1200" b="0" i="0">
+              <a:rPr sz="1250" b="0" i="0">
                 <a:solidFill>
                   <a:srgbClr val="3A4654"/>
                 </a:solidFill>
@@ -4524,8 +4524,8 @@
         </p:nvSpPr>
         <p:spPr>
           <a:xfrm>
-            <a:off x="685800" y="1956816"/>
-            <a:ext cx="384048" cy="384048"/>
+            <a:off x="685800" y="2551176"/>
+            <a:ext cx="420624" cy="420624"/>
           </a:xfrm>
           <a:prstGeom prst="ellipse">
             <a:avLst/>
@@ -4560,7 +4560,7 @@
           <a:p>
             <a:pPr algn="ctr"/>
             <a:r>
-              <a:rPr sz="1300" b="1" i="0">
+              <a:rPr sz="1400" b="1" i="0">
                 <a:solidFill>
                   <a:srgbClr val="FFFFFF"/>
                 </a:solidFill>
@@ -4579,8 +4579,8 @@
         </p:nvSpPr>
         <p:spPr>
           <a:xfrm>
-            <a:off x="1280160" y="1892808"/>
-            <a:ext cx="10332720" cy="274320"/>
+            <a:off x="1280160" y="2496312"/>
+            <a:ext cx="4526280" cy="292608"/>
           </a:xfrm>
           <a:prstGeom prst="rect">
             <a:avLst/>
@@ -4599,7 +4599,7 @@
               </a:spcAft>
             </a:pPr>
             <a:r>
-              <a:rPr sz="1600" b="1" i="0">
+              <a:rPr sz="1700" b="1" i="0">
                 <a:solidFill>
                   <a:srgbClr val="1B3A5C"/>
                 </a:solidFill>
@@ -4618,8 +4618,8 @@
         </p:nvSpPr>
         <p:spPr>
           <a:xfrm>
-            <a:off x="1280160" y="2167128"/>
-            <a:ext cx="10332720" cy="256032"/>
+            <a:off x="1280160" y="2798064"/>
+            <a:ext cx="4526280" cy="457200"/>
           </a:xfrm>
           <a:prstGeom prst="rect">
             <a:avLst/>
@@ -4638,7 +4638,7 @@
               </a:spcAft>
             </a:pPr>
             <a:r>
-              <a:rPr sz="1200" b="0" i="0">
+              <a:rPr sz="1250" b="0" i="0">
                 <a:solidFill>
                   <a:srgbClr val="3A4654"/>
                 </a:solidFill>
@@ -4657,8 +4657,8 @@
         </p:nvSpPr>
         <p:spPr>
           <a:xfrm>
-            <a:off x="685800" y="2615184"/>
-            <a:ext cx="384048" cy="384048"/>
+            <a:off x="685800" y="3630168"/>
+            <a:ext cx="420624" cy="420624"/>
           </a:xfrm>
           <a:prstGeom prst="ellipse">
             <a:avLst/>
@@ -4693,7 +4693,7 @@
           <a:p>
             <a:pPr algn="ctr"/>
             <a:r>
-              <a:rPr sz="1300" b="1" i="0">
+              <a:rPr sz="1400" b="1" i="0">
                 <a:solidFill>
                   <a:srgbClr val="FFFFFF"/>
                 </a:solidFill>
@@ -4712,8 +4712,8 @@
         </p:nvSpPr>
         <p:spPr>
           <a:xfrm>
-            <a:off x="1280160" y="2551176"/>
-            <a:ext cx="10332720" cy="274320"/>
+            <a:off x="1280160" y="3575304"/>
+            <a:ext cx="4526280" cy="292608"/>
           </a:xfrm>
           <a:prstGeom prst="rect">
             <a:avLst/>
@@ -4732,7 +4732,7 @@
               </a:spcAft>
             </a:pPr>
             <a:r>
-              <a:rPr sz="1600" b="1" i="0">
+              <a:rPr sz="1700" b="1" i="0">
                 <a:solidFill>
                   <a:srgbClr val="1B3A5C"/>
                 </a:solidFill>
@@ -4751,8 +4751,8 @@
         </p:nvSpPr>
         <p:spPr>
           <a:xfrm>
-            <a:off x="1280160" y="2825496"/>
-            <a:ext cx="10332720" cy="256032"/>
+            <a:off x="1280160" y="3877056"/>
+            <a:ext cx="4526280" cy="457200"/>
           </a:xfrm>
           <a:prstGeom prst="rect">
             <a:avLst/>
@@ -4771,7 +4771,7 @@
               </a:spcAft>
             </a:pPr>
             <a:r>
-              <a:rPr sz="1200" b="0" i="0">
+              <a:rPr sz="1250" b="0" i="0">
                 <a:solidFill>
                   <a:srgbClr val="3A4654"/>
                 </a:solidFill>
@@ -4790,8 +4790,8 @@
         </p:nvSpPr>
         <p:spPr>
           <a:xfrm>
-            <a:off x="685800" y="3273552"/>
-            <a:ext cx="384048" cy="384048"/>
+            <a:off x="685800" y="4709160"/>
+            <a:ext cx="420624" cy="420624"/>
           </a:xfrm>
           <a:prstGeom prst="ellipse">
             <a:avLst/>
@@ -4826,7 +4826,7 @@
           <a:p>
             <a:pPr algn="ctr"/>
             <a:r>
-              <a:rPr sz="1300" b="1" i="0">
+              <a:rPr sz="1400" b="1" i="0">
                 <a:solidFill>
                   <a:srgbClr val="FFFFFF"/>
                 </a:solidFill>
@@ -4845,8 +4845,8 @@
         </p:nvSpPr>
         <p:spPr>
           <a:xfrm>
-            <a:off x="1280160" y="3209544"/>
-            <a:ext cx="10332720" cy="274320"/>
+            <a:off x="1280160" y="4654296"/>
+            <a:ext cx="4526280" cy="292608"/>
           </a:xfrm>
           <a:prstGeom prst="rect">
             <a:avLst/>
@@ -4865,7 +4865,7 @@
               </a:spcAft>
             </a:pPr>
             <a:r>
-              <a:rPr sz="1600" b="1" i="0">
+              <a:rPr sz="1700" b="1" i="0">
                 <a:solidFill>
                   <a:srgbClr val="1B3A5C"/>
                 </a:solidFill>
@@ -4884,8 +4884,8 @@
         </p:nvSpPr>
         <p:spPr>
           <a:xfrm>
-            <a:off x="1280160" y="3483864"/>
-            <a:ext cx="10332720" cy="256032"/>
+            <a:off x="1280160" y="4956048"/>
+            <a:ext cx="4526280" cy="457200"/>
           </a:xfrm>
           <a:prstGeom prst="rect">
             <a:avLst/>
@@ -4904,7 +4904,7 @@
               </a:spcAft>
             </a:pPr>
             <a:r>
-              <a:rPr sz="1200" b="0" i="0">
+              <a:rPr sz="1250" b="0" i="0">
                 <a:solidFill>
                   <a:srgbClr val="3A4654"/>
                 </a:solidFill>
@@ -4923,8 +4923,8 @@
         </p:nvSpPr>
         <p:spPr>
           <a:xfrm>
-            <a:off x="685800" y="3931920"/>
-            <a:ext cx="384048" cy="384048"/>
+            <a:off x="6492240" y="1472184"/>
+            <a:ext cx="420624" cy="420624"/>
           </a:xfrm>
           <a:prstGeom prst="ellipse">
             <a:avLst/>
@@ -4959,7 +4959,7 @@
           <a:p>
             <a:pPr algn="ctr"/>
             <a:r>
-              <a:rPr sz="1300" b="1" i="0">
+              <a:rPr sz="1400" b="1" i="0">
                 <a:solidFill>
                   <a:srgbClr val="FFFFFF"/>
                 </a:solidFill>
@@ -4978,8 +4978,8 @@
         </p:nvSpPr>
         <p:spPr>
           <a:xfrm>
-            <a:off x="1280160" y="3867912"/>
-            <a:ext cx="10332720" cy="274320"/>
+            <a:off x="7086600" y="1417320"/>
+            <a:ext cx="4663440" cy="292608"/>
           </a:xfrm>
           <a:prstGeom prst="rect">
             <a:avLst/>
@@ -4998,7 +4998,7 @@
               </a:spcAft>
             </a:pPr>
             <a:r>
-              <a:rPr sz="1600" b="1" i="0">
+              <a:rPr sz="1700" b="1" i="0">
                 <a:solidFill>
                   <a:srgbClr val="1B3A5C"/>
                 </a:solidFill>
@@ -5017,8 +5017,8 @@
         </p:nvSpPr>
         <p:spPr>
           <a:xfrm>
-            <a:off x="1280160" y="4142232"/>
-            <a:ext cx="10332720" cy="256032"/>
+            <a:off x="7086600" y="1719072"/>
+            <a:ext cx="4663440" cy="457200"/>
           </a:xfrm>
           <a:prstGeom prst="rect">
             <a:avLst/>
@@ -5037,7 +5037,7 @@
               </a:spcAft>
             </a:pPr>
             <a:r>
-              <a:rPr sz="1200" b="0" i="0">
+              <a:rPr sz="1250" b="0" i="0">
                 <a:solidFill>
                   <a:srgbClr val="3A4654"/>
                 </a:solidFill>
@@ -5056,8 +5056,8 @@
         </p:nvSpPr>
         <p:spPr>
           <a:xfrm>
-            <a:off x="685800" y="4590288"/>
-            <a:ext cx="384048" cy="384048"/>
+            <a:off x="6492240" y="2551176"/>
+            <a:ext cx="420624" cy="420624"/>
           </a:xfrm>
           <a:prstGeom prst="ellipse">
             <a:avLst/>
@@ -5092,7 +5092,7 @@
           <a:p>
             <a:pPr algn="ctr"/>
             <a:r>
-              <a:rPr sz="1300" b="1" i="0">
+              <a:rPr sz="1400" b="1" i="0">
                 <a:solidFill>
                   <a:srgbClr val="FFFFFF"/>
                 </a:solidFill>
@@ -5111,8 +5111,8 @@
         </p:nvSpPr>
         <p:spPr>
           <a:xfrm>
-            <a:off x="1280160" y="4526280"/>
-            <a:ext cx="10332720" cy="274320"/>
+            <a:off x="7086600" y="2496312"/>
+            <a:ext cx="4663440" cy="292608"/>
           </a:xfrm>
           <a:prstGeom prst="rect">
             <a:avLst/>
@@ -5131,7 +5131,7 @@
               </a:spcAft>
             </a:pPr>
             <a:r>
-              <a:rPr sz="1600" b="1" i="0">
+              <a:rPr sz="1700" b="1" i="0">
                 <a:solidFill>
                   <a:srgbClr val="1B3A5C"/>
                 </a:solidFill>
@@ -5150,8 +5150,8 @@
         </p:nvSpPr>
         <p:spPr>
           <a:xfrm>
-            <a:off x="1280160" y="4800600"/>
-            <a:ext cx="10332720" cy="256032"/>
+            <a:off x="7086600" y="2798064"/>
+            <a:ext cx="4663440" cy="457200"/>
           </a:xfrm>
           <a:prstGeom prst="rect">
             <a:avLst/>
@@ -5170,13 +5170,13 @@
               </a:spcAft>
             </a:pPr>
             <a:r>
-              <a:rPr sz="1200" b="0" i="0">
+              <a:rPr sz="1250" b="0" i="0">
                 <a:solidFill>
                   <a:srgbClr val="3A4654"/>
                 </a:solidFill>
                 <a:latin typeface="Calibri"/>
               </a:rPr>
-              <a:t>6.1 a difficulty ladder · 6.2 what each stresses · 6.3 how to read the numbers</a:t>
+              <a:t>6.1 the difficulty ladder · 6.2 what each stresses · 6.3 the traps</a:t>
             </a:r>
           </a:p>
         </p:txBody>
@@ -5189,8 +5189,8 @@
         </p:nvSpPr>
         <p:spPr>
           <a:xfrm>
-            <a:off x="685800" y="5248656"/>
-            <a:ext cx="384048" cy="384048"/>
+            <a:off x="6492240" y="3630168"/>
+            <a:ext cx="420624" cy="420624"/>
           </a:xfrm>
           <a:prstGeom prst="ellipse">
             <a:avLst/>
@@ -5225,7 +5225,7 @@
           <a:p>
             <a:pPr algn="ctr"/>
             <a:r>
-              <a:rPr sz="1300" b="1" i="0">
+              <a:rPr sz="1400" b="1" i="0">
                 <a:solidFill>
                   <a:srgbClr val="FFFFFF"/>
                 </a:solidFill>
@@ -5244,8 +5244,8 @@
         </p:nvSpPr>
         <p:spPr>
           <a:xfrm>
-            <a:off x="1280160" y="5184648"/>
-            <a:ext cx="10332720" cy="274320"/>
+            <a:off x="7086600" y="3575304"/>
+            <a:ext cx="4663440" cy="292608"/>
           </a:xfrm>
           <a:prstGeom prst="rect">
             <a:avLst/>
@@ -5264,7 +5264,7 @@
               </a:spcAft>
             </a:pPr>
             <a:r>
-              <a:rPr sz="1600" b="1" i="0">
+              <a:rPr sz="1700" b="1" i="0">
                 <a:solidFill>
                   <a:srgbClr val="1B3A5C"/>
                 </a:solidFill>
@@ -5283,8 +5283,8 @@
         </p:nvSpPr>
         <p:spPr>
           <a:xfrm>
-            <a:off x="1280160" y="5458968"/>
-            <a:ext cx="10332720" cy="256032"/>
+            <a:off x="7086600" y="3877056"/>
+            <a:ext cx="4663440" cy="457200"/>
           </a:xfrm>
           <a:prstGeom prst="rect">
             <a:avLst/>
@@ -5303,7 +5303,7 @@
               </a:spcAft>
             </a:pPr>
             <a:r>
-              <a:rPr sz="1200" b="0" i="0">
+              <a:rPr sz="1250" b="0" i="0">
                 <a:solidFill>
                   <a:srgbClr val="3A4654"/>
                 </a:solidFill>
@@ -5314,6 +5314,42 @@
           </a:p>
         </p:txBody>
       </p:sp>
+      <p:cxnSp>
+        <p:nvCxnSpPr>
+          <p:cNvPr id="24" name="Connector 23"/>
+          <p:cNvCxnSpPr/>
+          <p:nvPr/>
+        </p:nvCxnSpPr>
+        <p:spPr>
+          <a:xfrm>
+            <a:off x="6080760" y="1371600"/>
+            <a:ext cx="0" cy="3886200"/>
+          </a:xfrm>
+          <a:prstGeom prst="line">
+            <a:avLst/>
+          </a:prstGeom>
+          <a:ln w="12700">
+            <a:solidFill>
+              <a:srgbClr val="C7CED6"/>
+            </a:solidFill>
+          </a:ln>
+          <a:effectLst/>
+        </p:spPr>
+        <p:style>
+          <a:lnRef idx="2">
+            <a:schemeClr val="accent1"/>
+          </a:lnRef>
+          <a:fillRef idx="0">
+            <a:schemeClr val="accent1"/>
+          </a:fillRef>
+          <a:effectRef idx="1">
+            <a:schemeClr val="accent1"/>
+          </a:effectRef>
+          <a:fontRef idx="minor">
+            <a:schemeClr val="tx1"/>
+          </a:fontRef>
+        </p:style>
+      </p:cxnSp>
     </p:spTree>
   </p:cSld>
   <p:clrMapOvr>

</xml_diff>

<commit_message>
docs: relabel S3 as "Shared store of benchmark run results" on the motif slide
Completes the role-based vocabulary on slide 4 only -- slides 5 and 6 keep the
concrete product names, which is the point of those slides.

Both store boxes widened and their type sized down to carry the longer labels, and
the arrows into them (5, 7, 8) re-centred on the new geometry along with 6b's
endpoint. Legend item 8 now reads "Service -> shared store".

Dropped the "shared sink" subtitle as redundant: the new label already says it.
Say so if you would rather keep it.

Verified: slide 4 contains no "S3", "shared sink", "MLflow" or "OTEL"; slides 5
and 6 still contain all of them, unchanged.

Co-Authored-By: Claude Opus 4.8 <noreply@anthropic.com>
</commit_message>
<xml_diff>
--- a/docs/BenchmarkingService.pptx
+++ b/docs/BenchmarkingService.pptx
@@ -15253,7 +15253,7 @@
         <p:spPr>
           <a:xfrm>
             <a:off x="365760" y="4343400"/>
-            <a:ext cx="1234440" cy="868680"/>
+            <a:ext cx="1325880" cy="868680"/>
           </a:xfrm>
           <a:prstGeom prst="roundRect">
             <a:avLst/>
@@ -15288,25 +15288,13 @@
           <a:p>
             <a:pPr algn="ctr"/>
             <a:r>
-              <a:rPr sz="1300" b="1" i="0">
+              <a:rPr sz="950" b="1" i="0">
                 <a:solidFill>
                   <a:srgbClr val="FFFFFF"/>
                 </a:solidFill>
                 <a:latin typeface="Calibri"/>
               </a:rPr>
-              <a:t>S3</a:t>
-            </a:r>
-          </a:p>
-          <a:p>
-            <a:pPr algn="ctr"/>
-            <a:r>
-              <a:rPr sz="1000" b="0" i="0">
-                <a:solidFill>
-                  <a:srgbClr val="EEEFF1"/>
-                </a:solidFill>
-                <a:latin typeface="Calibri"/>
-              </a:rPr>
-              <a:t>shared sink</a:t>
+              <a:t>Shared store of benchmark run results</a:t>
             </a:r>
           </a:p>
         </p:txBody>
@@ -15319,8 +15307,8 @@
         </p:nvSpPr>
         <p:spPr>
           <a:xfrm>
-            <a:off x="1691640" y="4343400"/>
-            <a:ext cx="1417320" cy="868680"/>
+            <a:off x="1783080" y="4343400"/>
+            <a:ext cx="1325880" cy="868680"/>
           </a:xfrm>
           <a:prstGeom prst="roundRect">
             <a:avLst/>
@@ -15355,7 +15343,7 @@
           <a:p>
             <a:pPr algn="ctr"/>
             <a:r>
-              <a:rPr sz="1150" b="1" i="0">
+              <a:rPr sz="1100" b="1" i="0">
                 <a:solidFill>
                   <a:srgbClr val="FFFFFF"/>
                 </a:solidFill>
@@ -16081,7 +16069,7 @@
         </p:nvCxnSpPr>
         <p:spPr>
           <a:xfrm>
-            <a:off x="1965960" y="3931920"/>
+            <a:off x="2148840" y="3931920"/>
             <a:ext cx="0" cy="411480"/>
           </a:xfrm>
           <a:prstGeom prst="line">
@@ -16118,7 +16106,7 @@
         </p:nvSpPr>
         <p:spPr>
           <a:xfrm>
-            <a:off x="1847088" y="4014215"/>
+            <a:off x="2029968" y="4014215"/>
             <a:ext cx="237744" cy="237744"/>
           </a:xfrm>
           <a:prstGeom prst="ellipse">
@@ -16266,8 +16254,8 @@
         </p:nvCxnSpPr>
         <p:spPr>
           <a:xfrm flipH="1">
-            <a:off x="3127248" y="4636008"/>
-            <a:ext cx="2496312" cy="137160"/>
+            <a:off x="3108960" y="4636008"/>
+            <a:ext cx="2514600" cy="137160"/>
           </a:xfrm>
           <a:prstGeom prst="line">
             <a:avLst/>
@@ -16359,7 +16347,7 @@
         </p:nvCxnSpPr>
         <p:spPr>
           <a:xfrm flipV="1">
-            <a:off x="2651760" y="3931920"/>
+            <a:off x="2788920" y="3931920"/>
             <a:ext cx="0" cy="411480"/>
           </a:xfrm>
           <a:prstGeom prst="line">
@@ -16396,7 +16384,7 @@
         </p:nvSpPr>
         <p:spPr>
           <a:xfrm>
-            <a:off x="2532888" y="4014215"/>
+            <a:off x="2670048" y="4014215"/>
             <a:ext cx="237744" cy="237744"/>
           </a:xfrm>
           <a:prstGeom prst="ellipse">
@@ -16451,7 +16439,7 @@
         </p:nvCxnSpPr>
         <p:spPr>
           <a:xfrm>
-            <a:off x="1005840" y="3931920"/>
+            <a:off x="960120" y="3931920"/>
             <a:ext cx="0" cy="411480"/>
           </a:xfrm>
           <a:prstGeom prst="line">
@@ -16488,7 +16476,7 @@
         </p:nvSpPr>
         <p:spPr>
           <a:xfrm>
-            <a:off x="685800" y="4014215"/>
+            <a:off x="640080" y="4014215"/>
             <a:ext cx="237744" cy="237744"/>
           </a:xfrm>
           <a:prstGeom prst="ellipse">
@@ -16750,7 +16738,7 @@
                 </a:solidFill>
                 <a:latin typeface="Calibri"/>
               </a:rPr>
-              <a:t>8  Service → S3:  export the run's artifacts</a:t>
+              <a:t>8  Service → shared store:  export the run's artifacts</a:t>
             </a:r>
           </a:p>
         </p:txBody>

</xml_diff>

<commit_message>
docs: trim the motif slide's arrow annotations
Arrows 1 and 3 now carry no elaboration, and the rest are reworded:

  1  Client → Service                       (was ": one bearer token, one hostname")
  2  ... create the harnessed workload      (was "create the workload")
  3  helper → harnessed workload            (was ": MCP tool + A2A agent")
  4  ... run and monitor benchmark execution (was "run the benchmark")
  5  ... emit the trace                     (was "emit the per-task trace")

Dropping the MCP-tool/A2A-agent detail from arrow 3 also keeps this slide free of
implementation names, which is consistent with the role-based labels it now uses --
those specifics belong on slides 5 and 6.

Corrected "monior" to "monitor" in the requested wording.

Co-Authored-By: Claude Opus 4.8 <noreply@anthropic.com>
</commit_message>
<xml_diff>
--- a/docs/BenchmarkingService.pptx
+++ b/docs/BenchmarkingService.pptx
@@ -16603,7 +16603,7 @@
                 </a:solidFill>
                 <a:latin typeface="Calibri"/>
               </a:rPr>
-              <a:t>1  Client → Service:  one bearer token, one hostname</a:t>
+              <a:t>1  Client → Service</a:t>
             </a:r>
           </a:p>
           <a:p>
@@ -16619,7 +16619,7 @@
                 </a:solidFill>
                 <a:latin typeface="Calibri"/>
               </a:rPr>
-              <a:t>2  Service → deployment helper:  create the workload</a:t>
+              <a:t>2  Service → deployment helper:  create the harnessed workload</a:t>
             </a:r>
           </a:p>
           <a:p>
@@ -16635,7 +16635,7 @@
                 </a:solidFill>
                 <a:latin typeface="Calibri"/>
               </a:rPr>
-              <a:t>3  helper → harnessed workload:  MCP tool + A2A agent</a:t>
+              <a:t>3  helper → harnessed workload</a:t>
             </a:r>
           </a:p>
           <a:p>
@@ -16651,7 +16651,7 @@
                 </a:solidFill>
                 <a:latin typeface="Calibri"/>
               </a:rPr>
-              <a:t>4  Service → harnessed workload:  run the benchmark</a:t>
+              <a:t>4  Service → harnessed workload:  run and monitor benchmark execution</a:t>
             </a:r>
           </a:p>
         </p:txBody>
@@ -16690,7 +16690,7 @@
                 </a:solidFill>
                 <a:latin typeface="Calibri"/>
               </a:rPr>
-              <a:t>5  Service → Experiment Tracker:  emit the per-task trace</a:t>
+              <a:t>5  Service → Experiment Tracker:  emit the trace</a:t>
             </a:r>
           </a:p>
           <a:p>

</xml_diff>

<commit_message>
docs: make the motif slide's Service box title-only
Dropped the three bullets ("deploy the workload / run the benchmark / read +
export results"). They restated arrows 2, 4 and 5/7/8 in different words than the
legend, so the same slide described the same flows twice and slightly
inconsistently. The box now matches the Client box: a role, nothing more.

That leaves slide 4 entirely free of implementation detail -- role-based labels,
trimmed annotations, no bullet lists -- which is what a motif slide is for. Slide 5
keeps its own bullet list, unchanged.

Same geometry (0.4-3.2 x 2.45-4.30), so every arrow leaving this box is untouched:
2 and 4 from its right edge, 5/7/8 from its bottom. Replacing the hand-built shape
with a plain box() call also drops nine lines of setup.

Co-Authored-By: Claude Opus 4.8 <noreply@anthropic.com>
</commit_message>
<xml_diff>
--- a/docs/BenchmarkingService.pptx
+++ b/docs/BenchmarkingService.pptx
@@ -15170,7 +15170,7 @@
           <a:solidFill>
             <a:srgbClr val="2E6FB5"/>
           </a:solidFill>
-          <a:ln>
+          <a:ln w="12700">
             <a:solidFill>
               <a:srgbClr val="2E6FB5"/>
             </a:solidFill>
@@ -15192,7 +15192,7 @@
           </a:fontRef>
         </p:style>
         <p:txBody>
-          <a:bodyPr rtlCol="0" anchor="t" wrap="square" lIns="101600" tIns="88900"/>
+          <a:bodyPr rtlCol="0" anchor="ctr" wrap="square" tIns="25400" bIns="25400"/>
           <a:lstStyle/>
           <a:p>
             <a:pPr algn="ctr"/>
@@ -15204,42 +15204,6 @@
                 <a:latin typeface="Calibri"/>
               </a:rPr>
               <a:t>Benchmarking Service</a:t>
-            </a:r>
-          </a:p>
-          <a:p>
-            <a:pPr algn="l" lvl="1"/>
-            <a:r>
-              <a:rPr sz="1100" b="0" i="0">
-                <a:solidFill>
-                  <a:srgbClr val="FFFFFF"/>
-                </a:solidFill>
-                <a:latin typeface="Calibri"/>
-              </a:rPr>
-              <a:t>• deploy the workload</a:t>
-            </a:r>
-          </a:p>
-          <a:p>
-            <a:pPr algn="l" lvl="1"/>
-            <a:r>
-              <a:rPr sz="1100" b="0" i="0">
-                <a:solidFill>
-                  <a:srgbClr val="FFFFFF"/>
-                </a:solidFill>
-                <a:latin typeface="Calibri"/>
-              </a:rPr>
-              <a:t>• run the benchmark</a:t>
-            </a:r>
-          </a:p>
-          <a:p>
-            <a:pPr algn="l" lvl="1"/>
-            <a:r>
-              <a:rPr sz="1100" b="0" i="0">
-                <a:solidFill>
-                  <a:srgbClr val="FFFFFF"/>
-                </a:solidFill>
-                <a:latin typeface="Calibri"/>
-              </a:rPr>
-              <a:t>• read + export results</a:t>
             </a:r>
           </a:p>
         </p:txBody>

</xml_diff>